<commit_message>
Update final presentation and recording script
</commit_message>
<xml_diff>
--- a/submission/DART_Presentation.pptx
+++ b/submission/DART_Presentation.pptx
@@ -2,27 +2,27 @@
 <file path=ppt/presentation.xml><?xml version="1.0" encoding="utf-8"?>
 <p:presentation xmlns:p="http://schemas.openxmlformats.org/presentationml/2006/main">
   <p:sldMasterIdLst>
-    <p:sldMasterId xmlns:r="http://schemas.openxmlformats.org/officeDocument/2006/relationships" id="2147483648" r:id="R9e92f6c2f15b4f7e"/>
+    <p:sldMasterId xmlns:r="http://schemas.openxmlformats.org/officeDocument/2006/relationships" id="2147483648" r:id="R5466a2b9479c43f2"/>
   </p:sldMasterIdLst>
   <p:notesMasterIdLst>
-    <p:notesMasterId xmlns:r="http://schemas.openxmlformats.org/officeDocument/2006/relationships" r:id="R5072ccb9fc3241e6"/>
+    <p:notesMasterId xmlns:r="http://schemas.openxmlformats.org/officeDocument/2006/relationships" r:id="Rce91eb103167445b"/>
   </p:notesMasterIdLst>
   <p:sldIdLst>
-    <p:sldId xmlns:r="http://schemas.openxmlformats.org/officeDocument/2006/relationships" id="256" r:id="Rb19672a95c2840af"/>
-    <p:sldId xmlns:r="http://schemas.openxmlformats.org/officeDocument/2006/relationships" id="257" r:id="R853fb9e5eeca4c80"/>
-    <p:sldId xmlns:r="http://schemas.openxmlformats.org/officeDocument/2006/relationships" id="258" r:id="R99c11699bce247fa"/>
-    <p:sldId xmlns:r="http://schemas.openxmlformats.org/officeDocument/2006/relationships" id="259" r:id="R73097b5e302147d8"/>
-    <p:sldId xmlns:r="http://schemas.openxmlformats.org/officeDocument/2006/relationships" id="260" r:id="Rc5167f06fdb24cae"/>
-    <p:sldId xmlns:r="http://schemas.openxmlformats.org/officeDocument/2006/relationships" id="261" r:id="Rc99a1af7eb7446fd"/>
-    <p:sldId xmlns:r="http://schemas.openxmlformats.org/officeDocument/2006/relationships" id="262" r:id="Rcb2c67e608b14a6e"/>
-    <p:sldId xmlns:r="http://schemas.openxmlformats.org/officeDocument/2006/relationships" id="263" r:id="Rcdeb763bf0554143"/>
-    <p:sldId xmlns:r="http://schemas.openxmlformats.org/officeDocument/2006/relationships" id="264" r:id="R85882b6c5d6745f4"/>
-    <p:sldId xmlns:r="http://schemas.openxmlformats.org/officeDocument/2006/relationships" id="265" r:id="R8ab7ecb8a5a14b99"/>
-    <p:sldId xmlns:r="http://schemas.openxmlformats.org/officeDocument/2006/relationships" id="266" r:id="R5041ea41b0ac47ce"/>
-    <p:sldId xmlns:r="http://schemas.openxmlformats.org/officeDocument/2006/relationships" id="267" r:id="Reb87629f77fa4d99"/>
-    <p:sldId xmlns:r="http://schemas.openxmlformats.org/officeDocument/2006/relationships" id="268" r:id="R8a568d4b0c9345de"/>
-    <p:sldId xmlns:r="http://schemas.openxmlformats.org/officeDocument/2006/relationships" id="269" r:id="R3fa1cb20301a4845"/>
-    <p:sldId xmlns:r="http://schemas.openxmlformats.org/officeDocument/2006/relationships" id="270" r:id="R5bda7d879ff24029"/>
+    <p:sldId xmlns:r="http://schemas.openxmlformats.org/officeDocument/2006/relationships" id="256" r:id="Rc5f2f74ce8eb47d2"/>
+    <p:sldId xmlns:r="http://schemas.openxmlformats.org/officeDocument/2006/relationships" id="257" r:id="R82a99045cc724390"/>
+    <p:sldId xmlns:r="http://schemas.openxmlformats.org/officeDocument/2006/relationships" id="258" r:id="R90746666c5e340d4"/>
+    <p:sldId xmlns:r="http://schemas.openxmlformats.org/officeDocument/2006/relationships" id="259" r:id="Re266aa2dd8774afa"/>
+    <p:sldId xmlns:r="http://schemas.openxmlformats.org/officeDocument/2006/relationships" id="260" r:id="Rcf8f5b54e22e457d"/>
+    <p:sldId xmlns:r="http://schemas.openxmlformats.org/officeDocument/2006/relationships" id="261" r:id="R8f7df79b40964b2d"/>
+    <p:sldId xmlns:r="http://schemas.openxmlformats.org/officeDocument/2006/relationships" id="262" r:id="R2b721c447c5d4890"/>
+    <p:sldId xmlns:r="http://schemas.openxmlformats.org/officeDocument/2006/relationships" id="263" r:id="R76f70639937e496e"/>
+    <p:sldId xmlns:r="http://schemas.openxmlformats.org/officeDocument/2006/relationships" id="264" r:id="Ree970847d01f4bfc"/>
+    <p:sldId xmlns:r="http://schemas.openxmlformats.org/officeDocument/2006/relationships" id="265" r:id="R0d42a09eacdf48c5"/>
+    <p:sldId xmlns:r="http://schemas.openxmlformats.org/officeDocument/2006/relationships" id="266" r:id="R92bdc7e7bae948f9"/>
+    <p:sldId xmlns:r="http://schemas.openxmlformats.org/officeDocument/2006/relationships" id="267" r:id="R06ff2ed570e8476b"/>
+    <p:sldId xmlns:r="http://schemas.openxmlformats.org/officeDocument/2006/relationships" id="268" r:id="R1f6f76cdcfee4f4e"/>
+    <p:sldId xmlns:r="http://schemas.openxmlformats.org/officeDocument/2006/relationships" id="269" r:id="Rd76e3c2a59324d47"/>
+    <p:sldId xmlns:r="http://schemas.openxmlformats.org/officeDocument/2006/relationships" id="270" r:id="Rbe3fab5f579a4ac2"/>
   </p:sldIdLst>
   <p:sldSz cx="12192000" cy="6858000"/>
   <p:notesSz cx="6858000" cy="9144000"/>
@@ -172,9 +172,9 @@
 </file>
 
 <file path=ppt/notesMasters/theme/theme3.xml><?xml version="1.0" encoding="utf-8"?>
-<a:theme xmlns:a="http://schemas.openxmlformats.org/drawingml/2006/main" name="ChatGPT">
+<a:theme xmlns:a="http://schemas.openxmlformats.org/drawingml/2006/main" name="DART Technical">
   <a:themeElements>
-    <a:clrScheme name="ChatGPT">
+    <a:clrScheme name="DART Technical">
       <a:dk1>
         <a:srgbClr val="000000"/>
       </a:dk1>
@@ -188,28 +188,28 @@
         <a:srgbClr val="E8E8E8"/>
       </a:lt2>
       <a:accent1>
-        <a:srgbClr val="156082"/>
+        <a:srgbClr val="00A6A6"/>
       </a:accent1>
       <a:accent2>
-        <a:srgbClr val="E97132"/>
+        <a:srgbClr val="FF6B5E"/>
       </a:accent2>
       <a:accent3>
-        <a:srgbClr val="196B24"/>
+        <a:srgbClr val="27AE60"/>
       </a:accent3>
       <a:accent4>
-        <a:srgbClr val="0F9ED5"/>
+        <a:srgbClr val="43D5C9"/>
       </a:accent4>
       <a:accent5>
-        <a:srgbClr val="A02B93"/>
+        <a:srgbClr val="5E7182"/>
       </a:accent5>
       <a:accent6>
-        <a:srgbClr val="4EA72E"/>
+        <a:srgbClr val="F5A623"/>
       </a:accent6>
       <a:hlink>
-        <a:srgbClr val="467886"/>
+        <a:srgbClr val="1565C0"/>
       </a:hlink>
       <a:folHlink>
-        <a:srgbClr val="96607D"/>
+        <a:srgbClr val="7B1FA2"/>
       </a:folHlink>
     </a:clrScheme>
     <a:fontScheme name="Office">
@@ -224,7 +224,7 @@
         <a:cs typeface="Calibri"/>
       </a:minorFont>
     </a:fontScheme>
-    <a:fmtScheme name="ChatGPT">
+    <a:fmtScheme name="DART Technical">
       <a:fillStyleLst>
         <a:solidFill>
           <a:schemeClr val="phClr"/>
@@ -551,7 +551,7 @@
           <a:lstStyle xmlns:a="http://schemas.openxmlformats.org/drawingml/2006/main"/>
           <a:p xmlns:a="http://schemas.openxmlformats.org/drawingml/2006/main">
             <a:r>
-              <a:t>รัน python3 -B demo.py แล้วชี้ผลทีละข้อ PASS ไม่ได้ดูแค่ว่ามี packet เข้า แต่ตรวจว่า critical sender confirm, มี forced ACK drop, มี retransmission, server เห็น duplicate และ process critical เท่ากับจำนวนที่สร้าง</a:t>
+              <a:t>รัน python3 -B demo.py แล้วชี้ผลทีละข้อ ผล PASS ตรวจทั้ง registration, critical confirmation, forced ACK suppression, retransmission, duplicate detection และจำนวน critical side effect ในรอบนี้ การกด duplicate มีขอบเขต 60 วินาทีตาม protocol specification</a:t>
             </a:r>
           </a:p>
           <a:p xmlns:a="http://schemas.openxmlformats.org/drawingml/2006/main">
@@ -751,7 +751,7 @@
           <a:lstStyle xmlns:a="http://schemas.openxmlformats.org/drawingml/2006/main"/>
           <a:p xmlns:a="http://schemas.openxmlformats.org/drawingml/2006/main">
             <a:r>
-              <a:t>ก่อนอวดผล ต้องอธิบาย fairness ทุก policy ใช้ event schedule เดียวกันและ fingerprint ต้องตรง ถ้า registration หรือ workload ไม่ตรง benchmark จะ abort Acceptance กับ confirmation และ attempted กับ sent bytes ถูกแยกนิยามชัดเจน</a:t>
+              <a:t>ก่อนอวดผล ต้องอธิบาย fairness ทุก policy ใช้ logical event schedule และ workload fingerprint เดียวกันใน loss/repeat เดียวกัน ชุดนี้มี 5 sensors นาน 4 วินาที 5 repeats ที่ loss 0%, 5%, 10%, 20% และ base seed 100 ทุก case บันทึก case simulation และ server seed แต่ individual drops ไม่ได้ packet-paired เพราะ ACK/retry ใช้ PRNG draws ต่างกัน</a:t>
             </a:r>
           </a:p>
           <a:p xmlns:a="http://schemas.openxmlformats.org/drawingml/2006/main">
@@ -776,7 +776,7 @@
           </a:p>
           <a:p xmlns:a="http://schemas.openxmlformats.org/drawingml/2006/main">
             <a:r>
-              <a:t>- docs/DEMO_GUIDE.md (benchmark method)</a:t>
+              <a:t>- docs/DEMO_GUIDE.md (benchmark method and caveats)</a:t>
             </a:r>
           </a:p>
           <a:p xmlns:a="http://schemas.openxmlformats.org/drawingml/2006/main">
@@ -851,7 +851,7 @@
           <a:lstStyle xmlns:a="http://schemas.openxmlformats.org/drawingml/2006/main"/>
           <a:p xmlns:a="http://schemas.openxmlformats.org/drawingml/2006/main">
             <a:r>
-              <a:t>อ่าน chart อย่างระวัง RAW ใช้ bytes ต่ำสุดแต่ไม่มี confirmation และ critical acceptance ไม่ครบ RELIABLE-ALL ได้ 100% แต่ใช้ bytes สูงสุด DART ยืนยัน critical 100% ในชุดนี้ด้วย overhead ระหว่างสองแบบ โดยยอมให้ normal/latest บางส่วนหาย ไม่พูดว่าชนะทุก metric</a:t>
+              <a:t>อ่าน chart อย่างระวัง RAW ใช้ attempted bytes ต่ำสุดแต่ไม่มี client confirmation และ server รับ critical 59/75 = 78.7% RELIABLE-ALL ยืนยันได้ 75/75 = 100.0% ส่วน DART ยืนยันได้ 74/75 = 98.7% DART ใช้ 67.3 B/value เทียบกับ RELIABLE-ALL 97.2 B/value โดยยอมให้ normal/latest บางส่วนหาย ผลนี้เป็น controlled loopback experiment ไม่ใช่ claim ว่าชนะทุกเครือข่ายหรือทุก protocol</a:t>
             </a:r>
           </a:p>
           <a:p xmlns:a="http://schemas.openxmlformats.org/drawingml/2006/main">
@@ -866,12 +866,12 @@
           </a:p>
           <a:p xmlns:a="http://schemas.openxmlformats.org/drawingml/2006/main">
             <a:r>
-              <a:t>- results/benchmark.json (20% loss summary)</a:t>
-            </a:r>
-          </a:p>
-          <a:p xmlns:a="http://schemas.openxmlformats.org/drawingml/2006/main">
-            <a:r>
-              <a:t>- benchmark.py (metric definitions)</a:t>
+              <a:t>- results/benchmark.json (20% loss summary and sample counts)</a:t>
+            </a:r>
+          </a:p>
+          <a:p xmlns:a="http://schemas.openxmlformats.org/drawingml/2006/main">
+            <a:r>
+              <a:t>- benchmark.py (metric definitions and seed derivation)</a:t>
             </a:r>
           </a:p>
           <a:p xmlns:a="http://schemas.openxmlformats.org/drawingml/2006/main">
@@ -946,7 +946,7 @@
           <a:lstStyle xmlns:a="http://schemas.openxmlformats.org/drawingml/2006/main"/>
           <a:p xmlns:a="http://schemas.openxmlformats.org/drawingml/2006/main">
             <a:r>
-              <a:t>สรุปความต่างและพูดข้อจำกัดเองก่อนถูกถาม นี่ช่วยให้ claim น่าเชื่อถือ DART ไม่ได้แทน TCP หรือ MQTT ทุกกรณี แต่เป็น protocol การศึกษาที่ทำให้เห็นว่าความหมายของข้อความกำหนด reliability ได้</a:t>
+              <a:t>เปรียบเทียบที่ semantics ไม่ใช่ประกาศว่า DART เร็วกว่ามาตรฐานที่ไม่ได้รัน TCP ให้ reliable ordered byte stream MQTT ใช้ broker และ QoS 0 1 2 ส่วน CoAP มี Confirmable กับ Non-confirmable DART เป็น prototype แบบ direct client-server ที่เพิ่ม batch latest critical และ TTL เพื่อสาธิต message-level trade-off พร้อมยอมรับว่าไม่มี security congestion control หรือ persistent state</a:t>
             </a:r>
           </a:p>
           <a:p xmlns:a="http://schemas.openxmlformats.org/drawingml/2006/main">
@@ -961,17 +961,27 @@
           </a:p>
           <a:p xmlns:a="http://schemas.openxmlformats.org/drawingml/2006/main">
             <a:r>
-              <a:t>- docs/PROTOCOL_SPEC.md (limitations)</a:t>
-            </a:r>
-          </a:p>
-          <a:p xmlns:a="http://schemas.openxmlformats.org/drawingml/2006/main">
-            <a:r>
-              <a:t>- docs/COURSE_ALIGNMENT.md</a:t>
-            </a:r>
-          </a:p>
-          <a:p xmlns:a="http://schemas.openxmlformats.org/drawingml/2006/main">
-            <a:r>
-              <a:t>- results/benchmark.json</a:t>
+              <a:t>- RFC 9293 - TCP: https://www.rfc-editor.org/info/rfc9293/</a:t>
+            </a:r>
+          </a:p>
+          <a:p xmlns:a="http://schemas.openxmlformats.org/drawingml/2006/main">
+            <a:r>
+              <a:t>- OASIS MQTT Version 5.0: https://docs.oasis-open.org/mqtt/mqtt/v5.0/mqtt-v5.0.html</a:t>
+            </a:r>
+          </a:p>
+          <a:p xmlns:a="http://schemas.openxmlformats.org/drawingml/2006/main">
+            <a:r>
+              <a:t>- RFC 7252 - CoAP: https://www.rfc-editor.org/info/rfc7252/</a:t>
+            </a:r>
+          </a:p>
+          <a:p xmlns:a="http://schemas.openxmlformats.org/drawingml/2006/main">
+            <a:r>
+              <a:t>- docs/PROTOCOL_SPEC.md (DART semantics and limitations)</a:t>
+            </a:r>
+          </a:p>
+          <a:p xmlns:a="http://schemas.openxmlformats.org/drawingml/2006/main">
+            <a:r>
+              <a:t>- results/benchmark.json (scope: DART wire-format policies only)</a:t>
             </a:r>
           </a:p>
           <a:p xmlns:a="http://schemas.openxmlformats.org/drawingml/2006/main">
@@ -1341,7 +1351,7 @@
           <a:lstStyle xmlns:a="http://schemas.openxmlformats.org/drawingml/2006/main"/>
           <a:p xmlns:a="http://schemas.openxmlformats.org/drawingml/2006/main">
             <a:r>
-              <a:t>อธิบายเหตุผลเลือก UDP แบบไม่โจมตี TCP เราต้องการ datagram boundary และเลือก ACK เฉพาะข้อความ จึงต้องสร้าง reliability primitives เอง ข้อแลกคือ prototype ยังไม่มี congestion control และ security</a:t>
+              <a:t>อธิบายเหตุผลเลือก UDP แบบไม่โจมตี TCP ตาม RFC 9293 TCP ให้ reliable ordered byte stream ส่วน DART ต้องการรักษา datagram boundary และเลือก ACK เฉพาะข้อความ จึงสร้าง reliability primitives เอง ข้อแลกคือ prototype ยังไม่มี congestion control และ security</a:t>
             </a:r>
           </a:p>
           <a:p xmlns:a="http://schemas.openxmlformats.org/drawingml/2006/main">
@@ -1352,6 +1362,11 @@
           <a:p xmlns:a="http://schemas.openxmlformats.org/drawingml/2006/main">
             <a:r>
               <a:t>[Sources]</a:t>
+            </a:r>
+          </a:p>
+          <a:p xmlns:a="http://schemas.openxmlformats.org/drawingml/2006/main">
+            <a:r>
+              <a:t>- RFC 9293 - Transmission Control Protocol: https://www.rfc-editor.org/info/rfc9293/</a:t>
             </a:r>
           </a:p>
           <a:p xmlns:a="http://schemas.openxmlformats.org/drawingml/2006/main">
@@ -1436,7 +1451,7 @@
           <a:lstStyle xmlns:a="http://schemas.openxmlformats.org/drawingml/2006/main"/>
           <a:p xmlns:a="http://schemas.openxmlformats.org/drawingml/2006/main">
             <a:r>
-              <a:t>นี่คือ slide แกนกลางของโปรเจกต์ ชี้ให้เห็นว่า batch ลด overhead, latest รักษาความสด และ critical ใช้ reliability เต็ม จุดเด่นไม่ได้อยู่ที่จำนวน feature แต่อยู่ที่ semantics ที่ต่างกันอย่างมีเหตุผล</a:t>
+              <a:t>นี่คือ slide แกนกลางของโปรเจกต์ batch ลด overhead, latest รักษาความสด ส่วน critical ใช้ ACK, timeout และ bounded retry พร้อมกด side effect ซ้ำใน duplicate cache 60 วินาที จุดเด่นคือ semantics ที่เลือกตามชนิดข้อความ ไม่ใช่ guarantee ถาวรหรือจำนวน feature</a:t>
             </a:r>
           </a:p>
           <a:p xmlns:a="http://schemas.openxmlformats.org/drawingml/2006/main">
@@ -1721,7 +1736,7 @@
           <a:lstStyle xmlns:a="http://schemas.openxmlformats.org/drawingml/2006/main"/>
           <a:p xmlns:a="http://schemas.openxmlformats.org/drawingml/2006/main">
             <a:r>
-              <a:t>เล่า timeline จากบนลงล่าง Server รับ critical ครั้งแรกและ process แล้ว แต่ ACK ถูกบังคับให้หาย Client timeout และส่ง seq เดิม Server เห็น duplicate จึงไม่ process ซ้ำ แต่ตอบ 409 ให้ client ยืนยันสำเร็จ</a:t>
+              <a:t>เล่า timeline จากบนลงล่าง Server รับ critical ครั้งแรกและ process แล้ว แต่ ACK ถูกบังคับไม่ให้ส่งก่อน sendto Client timeout และส่ง sequence เดิม Server เห็น duplicate จึงไม่ทำ side effect ซ้ำภายใน duplicate cache 60 วินาที และตอบ 409 ให้ client ยืนยันสำเร็จ นี่คือ process-once ภายใน cache window ไม่ใช่ exactly-once ตลอดกาล</a:t>
             </a:r>
           </a:p>
           <a:p xmlns:a="http://schemas.openxmlformats.org/drawingml/2006/main">
@@ -1736,7 +1751,7 @@
           </a:p>
           <a:p xmlns:a="http://schemas.openxmlformats.org/drawingml/2006/main">
             <a:r>
-              <a:t>- docs/PROTOCOL_SPEC.md (reliable flow and duplicate rules)</a:t>
+              <a:t>- docs/PROTOCOL_SPEC.md (reliable flow and duplicate-cache scope)</a:t>
             </a:r>
           </a:p>
           <a:p xmlns:a="http://schemas.openxmlformats.org/drawingml/2006/main">
@@ -1919,7 +1934,7 @@
   </p:cSld>
   <p:clrMap bg1="lt1" tx1="dk1" bg2="lt2" tx2="dk2" accent1="accent1" accent2="accent2" accent3="accent3" accent4="accent4" accent5="accent5" accent6="accent6" hlink="hlink" folHlink="folHlink"/>
   <p:sldLayoutIdLst>
-    <p:sldLayoutId xmlns:r="http://schemas.openxmlformats.org/officeDocument/2006/relationships" id="2147483649" r:id="Rd018161c9a7a4c8c"/>
+    <p:sldLayoutId xmlns:r="http://schemas.openxmlformats.org/officeDocument/2006/relationships" id="2147483649" r:id="R9cb5227a7a3e42dc"/>
   </p:sldLayoutIdLst>
   <p:txStyles>
     <p:titleStyle>
@@ -2202,9 +2217,9 @@
 </file>
 
 <file path=ppt/slideMasters/theme/theme2.xml><?xml version="1.0" encoding="utf-8"?>
-<a:theme xmlns:a="http://schemas.openxmlformats.org/drawingml/2006/main" name="ChatGPT">
+<a:theme xmlns:a="http://schemas.openxmlformats.org/drawingml/2006/main" name="DART Technical">
   <a:themeElements>
-    <a:clrScheme name="ChatGPT">
+    <a:clrScheme name="DART Technical">
       <a:dk1>
         <a:srgbClr val="000000"/>
       </a:dk1>
@@ -2218,28 +2233,28 @@
         <a:srgbClr val="E8E8E8"/>
       </a:lt2>
       <a:accent1>
-        <a:srgbClr val="156082"/>
+        <a:srgbClr val="00A6A6"/>
       </a:accent1>
       <a:accent2>
-        <a:srgbClr val="E97132"/>
+        <a:srgbClr val="FF6B5E"/>
       </a:accent2>
       <a:accent3>
-        <a:srgbClr val="196B24"/>
+        <a:srgbClr val="27AE60"/>
       </a:accent3>
       <a:accent4>
-        <a:srgbClr val="0F9ED5"/>
+        <a:srgbClr val="43D5C9"/>
       </a:accent4>
       <a:accent5>
-        <a:srgbClr val="A02B93"/>
+        <a:srgbClr val="5E7182"/>
       </a:accent5>
       <a:accent6>
-        <a:srgbClr val="4EA72E"/>
+        <a:srgbClr val="F5A623"/>
       </a:accent6>
       <a:hlink>
-        <a:srgbClr val="467886"/>
+        <a:srgbClr val="1565C0"/>
       </a:hlink>
       <a:folHlink>
-        <a:srgbClr val="96607D"/>
+        <a:srgbClr val="7B1FA2"/>
       </a:folHlink>
     </a:clrScheme>
     <a:fontScheme name="Office">
@@ -2254,7 +2269,7 @@
         <a:cs typeface="Calibri"/>
       </a:minorFont>
     </a:fontScheme>
-    <a:fmtScheme name="ChatGPT">
+    <a:fmtScheme name="DART Technical">
       <a:fillStyleLst>
         <a:solidFill>
           <a:schemeClr val="phClr"/>
@@ -2512,13 +2527,13 @@
               <c:formatCode>General</c:formatCode>
               <c:ptCount val="3"/>
               <c:pt idx="0">
-                <c:v>64.6</c:v>
+                <c:v>53.9</c:v>
               </c:pt>
               <c:pt idx="1">
-                <c:v>119.7</c:v>
+                <c:v>97.2</c:v>
               </c:pt>
               <c:pt idx="2">
-                <c:v>95.4</c:v>
+                <c:v>67.3</c:v>
               </c:pt>
             </c:numLit>
           </c:val>
@@ -4021,7 +4036,7 @@
                 <a:ea typeface="Tahoma"/>
                 <a:cs typeface="Tahoma"/>
               </a:rPr>
-              <a:t>เดโมบังคับให้ ACK หาย แล้วตรวจหลักฐานครบวงจร</a:t>
+              <a:t>เดโมระงับ ACK ก่อน sendto() แล้วตรวจครบวงจร</a:t>
             </a:r>
           </a:p>
         </p:txBody>
@@ -4083,7 +4098,7 @@
                 <a:ea typeface="Tahoma"/>
                 <a:cs typeface="Tahoma"/>
               </a:rPr>
-              <a:t>5/5 virtual sensors • 10% client-side loss • strict DART policy</a:t>
+              <a:t>5/5 virtual sensors • 10% client-side loss • DART policy • seed 42</a:t>
             </a:r>
           </a:p>
         </p:txBody>
@@ -4982,7 +4997,7 @@
                 <a:ea typeface="Tahoma"/>
                 <a:cs typeface="Tahoma"/>
               </a:rPr>
-              <a:t>ACK ถูกจงใจ drop</a:t>
+              <a:t>ระงับ ACK ก่อน sendto()</a:t>
             </a:r>
           </a:p>
         </p:txBody>
@@ -7571,7 +7586,7 @@
                 <a:ea typeface="Tahoma"/>
                 <a:cs typeface="Tahoma"/>
               </a:rPr>
-              <a:t>RAW • RELIABLE-ALL • DART | 0%, 10%, 20% simulated loss | repeats = 2</a:t>
+              <a:t>RAW • RELIABLE-ALL • DART | 0%, 5%, 10%, 20% loss | 5 sensors × 4s | repeats=5</a:t>
             </a:r>
           </a:p>
         </p:txBody>
@@ -8741,7 +8756,7 @@
                 <a:ea typeface="Tahoma"/>
                 <a:cs typeface="Tahoma"/>
               </a:rPr>
-              <a:t>seed เดียวกันไม่รับประกัน paired packet-level drops เมื่อ thread และ retries ต่างกัน จึงใช้หลาย repeats</a:t>
+              <a:t>base seed 100 • case/simulation/server seeds บันทึกทุก case • same seed ≠ paired drops • report ระบุ sample counts</a:t>
             </a:r>
           </a:p>
         </p:txBody>
@@ -8925,7 +8940,7 @@
                 <a:ea typeface="Tahoma"/>
                 <a:cs typeface="Tahoma"/>
               </a:rPr>
-              <a:t>ที่ 20% loss: DART ซื้อ reliability เฉพาะ critical</a:t>
+              <a:t>ที่ 20% loss: DART เลือก reliability ตามชนิดข้อความ</a:t>
             </a:r>
           </a:p>
         </p:txBody>
@@ -8987,7 +9002,7 @@
                 <a:ea typeface="Tahoma"/>
                 <a:cs typeface="Tahoma"/>
               </a:rPr>
-              <a:t>Attempted DART bytes ต่อ generated value - ต่ำกว่าการ reliable ทุกข้อความ</a:t>
+              <a:t>Attempted B/value • loopback • 5 sensors × 4s × 5 repeats • seed 100 • 20% app loss</a:t>
             </a:r>
           </a:p>
         </p:txBody>
@@ -9149,7 +9164,7 @@
       </p:sp>
       <p:graphicFrame>
         <p:nvGraphicFramePr>
-          <p:cNvPr id="23" name="Chart"/>
+          <p:cNvPr id="25" name="Chart"/>
           <p:cNvGraphicFramePr/>
           <p:nvPr/>
         </p:nvGraphicFramePr>
@@ -9159,7 +9174,7 @@
         </p:xfrm>
         <a:graphic xmlns:a="http://schemas.openxmlformats.org/drawingml/2006/main">
           <a:graphicData uri="http://schemas.openxmlformats.org/drawingml/2006/chart">
-            <c:chart xmlns:r="http://schemas.openxmlformats.org/officeDocument/2006/relationships" xmlns:c="http://schemas.openxmlformats.org/drawingml/2006/chart" r:id="Rcbfd176f2e3145ed"/>
+            <c:chart xmlns:r="http://schemas.openxmlformats.org/officeDocument/2006/relationships" xmlns:c="http://schemas.openxmlformats.org/drawingml/2006/chart" r:id="R45211a13f3824ebf"/>
           </a:graphicData>
         </a:graphic>
       </p:graphicFrame>
@@ -9313,7 +9328,7 @@
                 <a:ea typeface="Tahoma"/>
                 <a:cs typeface="Tahoma"/>
               </a:rPr>
-              <a:t>100%</a:t>
+              <a:t>98.7%</a:t>
             </a:r>
           </a:p>
         </p:txBody>
@@ -9375,7 +9390,7 @@
                 <a:ea typeface="Tahoma"/>
                 <a:cs typeface="Tahoma"/>
               </a:rPr>
-              <a:t>DART และ RELIABLE-ALL</a:t>
+              <a:t>DART • 74/75 confirmed</a:t>
             </a:r>
           </a:p>
         </p:txBody>
@@ -9533,7 +9548,7 @@
                 <a:ea typeface="Tahoma"/>
                 <a:cs typeface="Tahoma"/>
               </a:rPr>
-              <a:t>RAW critical accepted 83%</a:t>
+              <a:t>• RAW accepted 59/75 = 78.7%</a:t>
             </a:r>
           </a:p>
           <a:p xmlns:a="http://schemas.openxmlformats.org/drawingml/2006/main">
@@ -9563,7 +9578,7 @@
                 <a:ea typeface="Tahoma"/>
                 <a:cs typeface="Tahoma"/>
               </a:rPr>
-              <a:t>DART attempted 95.4 B/value</a:t>
+              <a:t>• DART 67.3 B/value</a:t>
             </a:r>
           </a:p>
           <a:p xmlns:a="http://schemas.openxmlformats.org/drawingml/2006/main">
@@ -9593,7 +9608,7 @@
                 <a:ea typeface="Tahoma"/>
                 <a:cs typeface="Tahoma"/>
               </a:rPr>
-              <a:t>RELIABLE-ALL 119.7 B/value</a:t>
+              <a:t>• RELIABLE-ALL 97.2 B/value</a:t>
             </a:r>
           </a:p>
         </p:txBody>
@@ -9839,7 +9854,7 @@
                 <a:ea typeface="Tahoma"/>
                 <a:cs typeface="Tahoma"/>
               </a:rPr>
-              <a:t>จุดเด่นคือ message-level trade-off ที่วัดได้ - ไม่ใช่ feature ของ GUI</a:t>
+              <a:t>เปรียบเทียบ semantics ตามมาตรฐาน • benchmark ไม่ได้รัน TCP, MQTT หรือ CoAP</a:t>
             </a:r>
           </a:p>
         </p:txBody>
@@ -10056,7 +10071,7 @@
                 <a:ea typeface="Tahoma"/>
                 <a:cs typeface="Tahoma"/>
               </a:rPr>
-              <a:t>จุดเด่น</a:t>
+              <a:t>เทียบกับวิธีที่มีอยู่</a:t>
             </a:r>
           </a:p>
         </p:txBody>
@@ -10121,7 +10136,7 @@
                 <a:ea typeface="Tahoma"/>
                 <a:cs typeface="Tahoma"/>
               </a:rPr>
-              <a:t>เลือก reliability ต่อ message class</a:t>
+              <a:t>• TCP: reliable ordered byte stream</a:t>
             </a:r>
           </a:p>
           <a:p xmlns:a="http://schemas.openxmlformats.org/drawingml/2006/main">
@@ -10151,7 +10166,7 @@
                 <a:ea typeface="Tahoma"/>
                 <a:cs typeface="Tahoma"/>
               </a:rPr>
-              <a:t>latest-state semantics ลดคุณค่าของค่าเก่า</a:t>
+              <a:t>• MQTT: broker + QoS 0 / 1 / 2</a:t>
             </a:r>
           </a:p>
           <a:p xmlns:a="http://schemas.openxmlformats.org/drawingml/2006/main">
@@ -10181,7 +10196,7 @@
                 <a:ea typeface="Tahoma"/>
                 <a:cs typeface="Tahoma"/>
               </a:rPr>
-              <a:t>ACK/retry พร้อม commit-safe duplicate handling</a:t>
+              <a:t>• CoAP: Confirmable / Non-confirmable</a:t>
             </a:r>
           </a:p>
           <a:p xmlns:a="http://schemas.openxmlformats.org/drawingml/2006/main">
@@ -10211,7 +10226,7 @@
                 <a:ea typeface="Tahoma"/>
                 <a:cs typeface="Tahoma"/>
               </a:rPr>
-              <a:t>wire format + Wireshark + status phrase ตรวจได้</a:t>
+              <a:t>• DART: batch / latest / critical + TTL</a:t>
             </a:r>
           </a:p>
           <a:p xmlns:a="http://schemas.openxmlformats.org/drawingml/2006/main">
@@ -10241,7 +10256,7 @@
                 <a:ea typeface="Tahoma"/>
                 <a:cs typeface="Tahoma"/>
               </a:rPr>
-              <a:t>benchmark แยก acceptance และ confirmation</a:t>
+              <a:t>• ไม่ได้อ้าง performance เหนือ 3 protocol</a:t>
             </a:r>
           </a:p>
         </p:txBody>
@@ -10334,7 +10349,7 @@
                 <a:ea typeface="Tahoma"/>
                 <a:cs typeface="Tahoma"/>
               </a:rPr>
-              <a:t>ข้อจำกัดที่ยอมรับ</a:t>
+              <a:t>DART เด่น / ข้อจำกัด</a:t>
             </a:r>
           </a:p>
         </p:txBody>
@@ -10399,7 +10414,7 @@
                 <a:ea typeface="Tahoma"/>
                 <a:cs typeface="Tahoma"/>
               </a:rPr>
-              <a:t>ยังไม่มี encryption / authentication</a:t>
+              <a:t>• วัด message-level trade-off ได้</a:t>
             </a:r>
           </a:p>
           <a:p xmlns:a="http://schemas.openxmlformats.org/drawingml/2006/main">
@@ -10429,7 +10444,7 @@
                 <a:ea typeface="Tahoma"/>
                 <a:cs typeface="Tahoma"/>
               </a:rPr>
-              <a:t>ยังไม่มี congestion control และ windowing</a:t>
+              <a:t>• Wireshark + status ตรวจบน wire</a:t>
             </a:r>
           </a:p>
           <a:p xmlns:a="http://schemas.openxmlformats.org/drawingml/2006/main">
@@ -10459,7 +10474,7 @@
                 <a:ea typeface="Tahoma"/>
                 <a:cs typeface="Tahoma"/>
               </a:rPr>
-              <a:t>session/state อยู่ใน memory</a:t>
+              <a:t>• ไม่มี encryption / authentication</a:t>
             </a:r>
           </a:p>
           <a:p xmlns:a="http://schemas.openxmlformats.org/drawingml/2006/main">
@@ -10489,7 +10504,7 @@
                 <a:ea typeface="Tahoma"/>
                 <a:cs typeface="Tahoma"/>
               </a:rPr>
-              <a:t>loopback loss ไม่ใช่ topology จริง</a:t>
+              <a:t>• ไม่มี congestion control / persistent state</a:t>
             </a:r>
           </a:p>
           <a:p xmlns:a="http://schemas.openxmlformats.org/drawingml/2006/main">
@@ -10519,7 +10534,7 @@
                 <a:ea typeface="Tahoma"/>
                 <a:cs typeface="Tahoma"/>
               </a:rPr>
-              <a:t>prototype เพื่อการเรียน ไม่ใช่มาตรฐาน Internet</a:t>
+              <a:t>• prototype เพื่อการเรียน ไม่ใช่มาตรฐาน</a:t>
             </a:r>
           </a:p>
         </p:txBody>
@@ -12576,84 +12591,36 @@
           </a:bodyPr>
           <a:lstStyle xmlns:a="http://schemas.openxmlformats.org/drawingml/2006/main"/>
           <a:p xmlns:a="http://schemas.openxmlformats.org/drawingml/2006/main">
-            <a:pPr algn="l">
+            <a:pPr>
               <a:lnSpc>
                 <a:spcPct val="125000"/>
               </a:lnSpc>
               <a:buNone/>
-              <a:defRPr sz="1725" b="0">
-                <a:solidFill>
-                  <a:srgbClr val="172A3A"/>
-                </a:solidFill>
-                <a:latin typeface="Tahoma"/>
-                <a:ea typeface="Tahoma"/>
-                <a:cs typeface="Tahoma"/>
-              </a:defRPr>
-            </a:pPr>
-            <a:r>
-              <a:rPr sz="1725" b="0">
-                <a:solidFill>
-                  <a:srgbClr val="172A3A"/>
-                </a:solidFill>
-                <a:latin typeface="Tahoma"/>
-                <a:ea typeface="Tahoma"/>
-                <a:cs typeface="Tahoma"/>
-              </a:rPr>
+            </a:pPr>
+            <a:r>
               <a:t>ไฟไหม้ต้องยืนยัน</a:t>
             </a:r>
           </a:p>
           <a:p xmlns:a="http://schemas.openxmlformats.org/drawingml/2006/main">
-            <a:pPr algn="l">
+            <a:pPr>
               <a:lnSpc>
                 <a:spcPct val="125000"/>
               </a:lnSpc>
               <a:buNone/>
-              <a:defRPr sz="1725" b="0">
-                <a:solidFill>
-                  <a:srgbClr val="172A3A"/>
-                </a:solidFill>
-                <a:latin typeface="Tahoma"/>
-                <a:ea typeface="Tahoma"/>
-                <a:cs typeface="Tahoma"/>
-              </a:defRPr>
-            </a:pPr>
-            <a:r>
-              <a:rPr sz="1725" b="0">
-                <a:solidFill>
-                  <a:srgbClr val="172A3A"/>
-                </a:solidFill>
-                <a:latin typeface="Tahoma"/>
-                <a:ea typeface="Tahoma"/>
-                <a:cs typeface="Tahoma"/>
-              </a:rPr>
-              <a:t>retry ได้แต่ห้ามทำซ้ำ</a:t>
-            </a:r>
-          </a:p>
-          <a:p xmlns:a="http://schemas.openxmlformats.org/drawingml/2006/main">
-            <a:pPr algn="l">
+            </a:pPr>
+            <a:r>
+              <a:t>ACK + timeout + bounded retry</a:t>
+            </a:r>
+          </a:p>
+          <a:p xmlns:a="http://schemas.openxmlformats.org/drawingml/2006/main">
+            <a:pPr>
               <a:lnSpc>
                 <a:spcPct val="125000"/>
               </a:lnSpc>
               <a:buNone/>
-              <a:defRPr sz="1725" b="0">
-                <a:solidFill>
-                  <a:srgbClr val="172A3A"/>
-                </a:solidFill>
-                <a:latin typeface="Tahoma"/>
-                <a:ea typeface="Tahoma"/>
-                <a:cs typeface="Tahoma"/>
-              </a:defRPr>
-            </a:pPr>
-            <a:r>
-              <a:rPr sz="1725" b="0">
-                <a:solidFill>
-                  <a:srgbClr val="172A3A"/>
-                </a:solidFill>
-                <a:latin typeface="Tahoma"/>
-                <a:ea typeface="Tahoma"/>
-                <a:cs typeface="Tahoma"/>
-              </a:rPr>
-              <a:t>เป้าหมายคือ confirmation</a:t>
+            </a:pPr>
+            <a:r>
+              <a:t>กด side effect ซ้ำใน cache 60s</a:t>
             </a:r>
           </a:p>
         </p:txBody>
@@ -15377,7 +15344,8 @@
                 <a:ea typeface="Tahoma"/>
                 <a:cs typeface="Tahoma"/>
               </a:rPr>
-              <a:t>ทั้ง stream</a:t>
+              <a:t>reliable ordered
+byte stream</a:t>
             </a:r>
           </a:p>
         </p:txBody>
@@ -17332,7 +17300,7 @@
         </p:spPr>
         <p:txBody>
           <a:bodyPr xmlns:a="http://schemas.openxmlformats.org/drawingml/2006/main" lIns="0" tIns="0" rIns="0" bIns="0" anchor="t">
-            <a:normAutofit fontScale="100000"/>
+            <a:normAutofit fontScale="94697"/>
           </a:bodyPr>
           <a:lstStyle xmlns:a="http://schemas.openxmlformats.org/drawingml/2006/main"/>
           <a:p xmlns:a="http://schemas.openxmlformats.org/drawingml/2006/main">
@@ -17359,7 +17327,7 @@
                 <a:ea typeface="Tahoma"/>
                 <a:cs typeface="Tahoma"/>
               </a:rPr>
-              <a:t>ACK + timeout + retry</a:t>
+              <a:t>ACK + timeout + bounded retry</a:t>
             </a:r>
           </a:p>
         </p:txBody>
@@ -17421,7 +17389,8 @@
                 <a:ea typeface="Tahoma"/>
                 <a:cs typeface="Tahoma"/>
               </a:rPr>
-              <a:t>ยืนยัน แต่ process ครั้งเดียว</a:t>
+              <a:t>กด duplicate ใน
+cache 60 วินาที</a:t>
             </a:r>
           </a:p>
         </p:txBody>
@@ -18378,7 +18347,7 @@
                 <a:ea typeface="Tahoma"/>
                 <a:cs typeface="Tahoma"/>
               </a:rPr>
-              <a:t>TIME + RESULT</a:t>
+              <a:t>TIME + LENGTH</a:t>
             </a:r>
           </a:p>
         </p:txBody>
@@ -18419,7 +18388,7 @@
           <a:p xmlns:a="http://schemas.openxmlformats.org/drawingml/2006/main">
             <a:pPr algn="ctr">
               <a:lnSpc>
-                <a:spcPct val="120000"/>
+                <a:spcPct val="100000"/>
               </a:lnSpc>
               <a:buNone/>
               <a:defRPr sz="1650" b="1">
@@ -18446,7 +18415,7 @@
           <a:p xmlns:a="http://schemas.openxmlformats.org/drawingml/2006/main">
             <a:pPr algn="ctr">
               <a:lnSpc>
-                <a:spcPct val="120000"/>
+                <a:spcPct val="100000"/>
               </a:lnSpc>
               <a:buNone/>
               <a:defRPr sz="1650" b="1">
@@ -18467,7 +18436,7 @@
                 <a:ea typeface="Tahoma"/>
                 <a:cs typeface="Tahoma"/>
               </a:rPr>
-              <a:t>status_code</a:t>
+              <a:t>payload_length</a:t>
             </a:r>
           </a:p>
         </p:txBody>
@@ -18593,7 +18562,7 @@
                 <a:ea typeface="Tahoma"/>
                 <a:cs typeface="Tahoma"/>
               </a:rPr>
-              <a:t>INTEGRITY</a:t>
+              <a:t>RESULT + INTEGRITY</a:t>
             </a:r>
           </a:p>
         </p:txBody>
@@ -18634,7 +18603,7 @@
           <a:p xmlns:a="http://schemas.openxmlformats.org/drawingml/2006/main">
             <a:pPr algn="ctr">
               <a:lnSpc>
-                <a:spcPct val="120000"/>
+                <a:spcPct val="100000"/>
               </a:lnSpc>
               <a:buNone/>
               <a:defRPr sz="1650" b="1">
@@ -18655,13 +18624,13 @@
                 <a:ea typeface="Tahoma"/>
                 <a:cs typeface="Tahoma"/>
               </a:rPr>
-              <a:t>payload_length</a:t>
+              <a:t>status_code</a:t>
             </a:r>
           </a:p>
           <a:p xmlns:a="http://schemas.openxmlformats.org/drawingml/2006/main">
             <a:pPr algn="ctr">
               <a:lnSpc>
-                <a:spcPct val="120000"/>
+                <a:spcPct val="100000"/>
               </a:lnSpc>
               <a:buNone/>
               <a:defRPr sz="1650" b="1">
@@ -20945,7 +20914,7 @@
         </p:spPr>
         <p:txBody>
           <a:bodyPr xmlns:a="http://schemas.openxmlformats.org/drawingml/2006/main" lIns="0" tIns="0" rIns="0" bIns="0" anchor="t">
-            <a:normAutofit fontScale="100000"/>
+            <a:normAutofit fontScale="85196"/>
           </a:bodyPr>
           <a:lstStyle xmlns:a="http://schemas.openxmlformats.org/drawingml/2006/main"/>
           <a:p xmlns:a="http://schemas.openxmlformats.org/drawingml/2006/main">
@@ -20972,7 +20941,7 @@
                 <a:ea typeface="Tahoma"/>
                 <a:cs typeface="Tahoma"/>
               </a:rPr>
-              <a:t>ACK หายได้ แต่เหตุสำคัญต้องไม่ถูก process ซ้ำ</a:t>
+              <a:t>ระงับ ACK ก่อน sendto() • กด side effect ซ้ำภายใน cache 60 วินาที</a:t>
             </a:r>
           </a:p>
         </p:txBody>
@@ -21623,7 +21592,7 @@
                 <a:ea typeface="Tahoma"/>
                 <a:cs typeface="Tahoma"/>
               </a:rPr>
-              <a:t>ACK 202</a:t>
+              <a:t>ACK path (would be 202)</a:t>
             </a:r>
           </a:p>
         </p:txBody>
@@ -21685,7 +21654,7 @@
                 <a:ea typeface="Tahoma"/>
                 <a:cs typeface="Tahoma"/>
               </a:rPr>
-              <a:t>simulated drop ×</a:t>
+              <a:t>suppressed before sendto ×</a:t>
             </a:r>
           </a:p>
         </p:txBody>
@@ -23662,9 +23631,9 @@
 </file>
 
 <file path=ppt/theme/theme1.xml><?xml version="1.0" encoding="utf-8"?>
-<a:theme xmlns:a="http://schemas.openxmlformats.org/drawingml/2006/main" name="ChatGPT">
+<a:theme xmlns:a="http://schemas.openxmlformats.org/drawingml/2006/main" name="DART Technical">
   <a:themeElements>
-    <a:clrScheme name="ChatGPT">
+    <a:clrScheme name="DART Technical">
       <a:dk1>
         <a:srgbClr val="000000"/>
       </a:dk1>
@@ -23678,28 +23647,28 @@
         <a:srgbClr val="E8E8E8"/>
       </a:lt2>
       <a:accent1>
-        <a:srgbClr val="156082"/>
+        <a:srgbClr val="00A6A6"/>
       </a:accent1>
       <a:accent2>
-        <a:srgbClr val="E97132"/>
+        <a:srgbClr val="FF6B5E"/>
       </a:accent2>
       <a:accent3>
-        <a:srgbClr val="196B24"/>
+        <a:srgbClr val="27AE60"/>
       </a:accent3>
       <a:accent4>
-        <a:srgbClr val="0F9ED5"/>
+        <a:srgbClr val="43D5C9"/>
       </a:accent4>
       <a:accent5>
-        <a:srgbClr val="A02B93"/>
+        <a:srgbClr val="5E7182"/>
       </a:accent5>
       <a:accent6>
-        <a:srgbClr val="4EA72E"/>
+        <a:srgbClr val="F5A623"/>
       </a:accent6>
       <a:hlink>
-        <a:srgbClr val="467886"/>
+        <a:srgbClr val="1565C0"/>
       </a:hlink>
       <a:folHlink>
-        <a:srgbClr val="96607D"/>
+        <a:srgbClr val="7B1FA2"/>
       </a:folHlink>
     </a:clrScheme>
     <a:fontScheme name="Office">
@@ -23714,7 +23683,7 @@
         <a:cs typeface="Calibri"/>
       </a:minorFont>
     </a:fontScheme>
-    <a:fmtScheme name="ChatGPT">
+    <a:fmtScheme name="DART Technical">
       <a:fillStyleLst>
         <a:solidFill>
           <a:schemeClr val="phClr"/>

</xml_diff>